<commit_message>
Rename website to HOC TIENG VIET CUNG AI
</commit_message>
<xml_diff>
--- a/public/CUNG_EM_HOC_TIENG_VIET_AI_Phan_Thi_Hien.pptx
+++ b/public/CUNG_EM_HOC_TIENG_VIET_AI_Phan_Thi_Hien.pptx
@@ -6473,7 +6473,7 @@
                 <a:ea typeface="Aptos"/>
                 <a:cs typeface="Aptos"/>
               </a:rPr>
-              <a:t>Xây dựng ứng dụng web thông minh CÙNG EM HỌC TIẾNG VIỆT - AI tích hợp nhận diện giọng nói, chấm điểm phát âm và nhận xét cá nhân hóa 1 kèm 1.</a:t>
+              <a:t>Xây dựng ứng dụng web thông minh HỌC TIẾNG VIỆT CÙNG AI tích hợp nhận diện giọng nói, chấm điểm phát âm và nhận xét cá nhân hóa 1 kèm 1.</a:t>
             </a:r>
           </a:p>
           <a:p xmlns:a="http://schemas.openxmlformats.org/drawingml/2006/main">
@@ -7058,7 +7058,7 @@
                 <a:ea typeface="Aptos"/>
                 <a:cs typeface="Aptos"/>
               </a:rPr>
-              <a:t>Ứng dụng web CÙNG EM HỌC TIẾNG VIỆT - AI (Tập 1: 83 bài Âm - Vần - Mô hình tiếng; Tập 2: 8 chủ điểm Đọc hiểu &amp; Tập viết chuẩn SGK Kết nối tri thức).</a:t>
+              <a:t>Ứng dụng web HỌC TIẾNG VIỆT CÙNG AI (Tập 1: 83 bài Âm - Vần - Mô hình tiếng; Tập 2: 8 chủ điểm Đọc hiểu &amp; Tập viết chuẩn SGK Kết nối tri thức).</a:t>
             </a:r>
           </a:p>
           <a:p xmlns:a="http://schemas.openxmlformats.org/drawingml/2006/main">
@@ -8432,7 +8432,7 @@
                 <a:ea typeface="Aptos Bold"/>
                 <a:cs typeface="Aptos Bold"/>
               </a:rPr>
-              <a:t>Giải pháp CÙNG EM HỌC TIẾNG VIỆT - AI: </a:t>
+              <a:t>Giải pháp HỌC TIẾNG VIỆT CÙNG AI: </a:t>
             </a:r>
             <a:r>
               <a:rPr lang="vi-VN" sz="2150">

</xml_diff>